<commit_message>
brand: add Boursea logomark and wire it into the app
Replaces the generic lucide TrendingUp icon in the web Logo component
with the real Boursea mark (a wave dipping into a decisive uptrend
breakout), and regenerates the mobile app icon set (iOS icon, Android
adaptive icon layers, splash icon, favicon) plus the web favicon.ico
from the same vector source. Also updates the pptx deck's title/closing
slides and footer with the finished mark, and saves the source SVG/PNG
assets under docs/marketing/brand/.

Co-Authored-By: Claude Sonnet 5 <noreply@anthropic.com>
</commit_message>
<xml_diff>
--- a/docs/marketing/Boursea-Sunum.pptx
+++ b/docs/marketing/Boursea-Sunum.pptx
@@ -2122,29 +2122,33 @@
           <a:ln/>
         </p:spPr>
       </p:sp>
-      <p:sp>
-        <p:nvSpPr>
-          <p:cNvPr id="5" name="Shape 3"/>
-          <p:cNvSpPr/>
-          <p:nvPr/>
-        </p:nvSpPr>
-        <p:spPr>
-          <a:xfrm rot="16200000">
-            <a:off x="822960" y="1234440"/>
-            <a:ext cx="1005840" cy="868680"/>
-          </a:xfrm>
-          <a:prstGeom prst="chevron">
-            <a:avLst/>
-          </a:prstGeom>
-          <a:solidFill>
-            <a:srgbClr val="3B82F6"/>
-          </a:solidFill>
-          <a:ln/>
-        </p:spPr>
-      </p:sp>
-      <p:sp>
-        <p:nvSpPr>
-          <p:cNvPr id="6" name="Text 4"/>
+      <p:pic>
+        <p:nvPicPr>
+          <p:cNvPr id="5" name="Image 0" descr="/private/tmp/claude-501/-Users-ulasbudak-Desktop-borsa-app/e78c8e07-ac03-4beb-bcc3-115504839e4a/scratchpad/deck/logo_mark_accent.png">    </p:cNvPr>
+          <p:cNvPicPr>
+            <a:picLocks noChangeAspect="1"/>
+          </p:cNvPicPr>
+          <p:nvPr/>
+        </p:nvPicPr>
+        <p:blipFill>
+          <a:blip r:embed="rId1"/>
+          <a:stretch>
+            <a:fillRect/>
+          </a:stretch>
+        </p:blipFill>
+        <p:spPr>
+          <a:xfrm>
+            <a:off x="777240" y="1188720"/>
+            <a:ext cx="960120" cy="960120"/>
+          </a:xfrm>
+          <a:prstGeom prst="rect">
+            <a:avLst/>
+          </a:prstGeom>
+        </p:spPr>
+      </p:pic>
+      <p:sp>
+        <p:nvSpPr>
+          <p:cNvPr id="6" name="Text 3"/>
           <p:cNvSpPr txBox="1"/>
           <p:nvPr/>
         </p:nvSpPr>
@@ -2183,7 +2187,7 @@
       </p:sp>
       <p:sp>
         <p:nvSpPr>
-          <p:cNvPr id="7" name="Text 5"/>
+          <p:cNvPr id="7" name="Text 4"/>
           <p:cNvSpPr txBox="1"/>
           <p:nvPr/>
         </p:nvSpPr>
@@ -2222,7 +2226,7 @@
       </p:sp>
       <p:sp>
         <p:nvSpPr>
-          <p:cNvPr id="8" name="Text 6"/>
+          <p:cNvPr id="8" name="Text 5"/>
           <p:cNvSpPr txBox="1"/>
           <p:nvPr/>
         </p:nvSpPr>
@@ -2264,7 +2268,7 @@
       </p:sp>
       <p:sp>
         <p:nvSpPr>
-          <p:cNvPr id="9" name="Text 7"/>
+          <p:cNvPr id="9" name="Text 6"/>
           <p:cNvSpPr txBox="1"/>
           <p:nvPr/>
         </p:nvSpPr>
@@ -3463,15 +3467,39 @@
           </a:p>
         </p:txBody>
       </p:sp>
-      <p:sp>
-        <p:nvSpPr>
-          <p:cNvPr id="35" name="Text 28"/>
-          <p:cNvSpPr txBox="1"/>
-          <p:nvPr/>
-        </p:nvSpPr>
-        <p:spPr>
-          <a:xfrm>
-            <a:off x="548640" y="6400800"/>
+      <p:pic>
+        <p:nvPicPr>
+          <p:cNvPr id="35" name="Image 5" descr="/private/tmp/claude-501/-Users-ulasbudak-Desktop-borsa-app/e78c8e07-ac03-4beb-bcc3-115504839e4a/scratchpad/deck/logo_mark_accent.png">    </p:cNvPr>
+          <p:cNvPicPr>
+            <a:picLocks noChangeAspect="1"/>
+          </p:cNvPicPr>
+          <p:nvPr/>
+        </p:nvPicPr>
+        <p:blipFill>
+          <a:blip r:embed="rId6"/>
+          <a:stretch>
+            <a:fillRect/>
+          </a:stretch>
+        </p:blipFill>
+        <p:spPr>
+          <a:xfrm>
+            <a:off x="548640" y="6437376"/>
+            <a:ext cx="173736" cy="173736"/>
+          </a:xfrm>
+          <a:prstGeom prst="rect">
+            <a:avLst/>
+          </a:prstGeom>
+        </p:spPr>
+      </p:pic>
+      <p:sp>
+        <p:nvSpPr>
+          <p:cNvPr id="36" name="Text 28"/>
+          <p:cNvSpPr txBox="1"/>
+          <p:nvPr/>
+        </p:nvSpPr>
+        <p:spPr>
+          <a:xfrm>
+            <a:off x="786384" y="6400800"/>
             <a:ext cx="2743200" cy="274320"/>
           </a:xfrm>
           <a:prstGeom prst="rect">
@@ -4452,15 +4480,39 @@
           </a:p>
         </p:txBody>
       </p:sp>
-      <p:sp>
-        <p:nvSpPr>
-          <p:cNvPr id="29" name="Text 22"/>
-          <p:cNvSpPr txBox="1"/>
-          <p:nvPr/>
-        </p:nvSpPr>
-        <p:spPr>
-          <a:xfrm>
-            <a:off x="548640" y="6400800"/>
+      <p:pic>
+        <p:nvPicPr>
+          <p:cNvPr id="29" name="Image 5" descr="/private/tmp/claude-501/-Users-ulasbudak-Desktop-borsa-app/e78c8e07-ac03-4beb-bcc3-115504839e4a/scratchpad/deck/logo_mark_accent.png">    </p:cNvPr>
+          <p:cNvPicPr>
+            <a:picLocks noChangeAspect="1"/>
+          </p:cNvPicPr>
+          <p:nvPr/>
+        </p:nvPicPr>
+        <p:blipFill>
+          <a:blip r:embed="rId6"/>
+          <a:stretch>
+            <a:fillRect/>
+          </a:stretch>
+        </p:blipFill>
+        <p:spPr>
+          <a:xfrm>
+            <a:off x="548640" y="6437376"/>
+            <a:ext cx="173736" cy="173736"/>
+          </a:xfrm>
+          <a:prstGeom prst="rect">
+            <a:avLst/>
+          </a:prstGeom>
+        </p:spPr>
+      </p:pic>
+      <p:sp>
+        <p:nvSpPr>
+          <p:cNvPr id="30" name="Text 22"/>
+          <p:cNvSpPr txBox="1"/>
+          <p:nvPr/>
+        </p:nvSpPr>
+        <p:spPr>
+          <a:xfrm>
+            <a:off x="786384" y="6400800"/>
             <a:ext cx="2743200" cy="274320"/>
           </a:xfrm>
           <a:prstGeom prst="rect">
@@ -5049,15 +5101,39 @@
           </a:p>
         </p:txBody>
       </p:sp>
-      <p:sp>
-        <p:nvSpPr>
-          <p:cNvPr id="15" name="Text 11"/>
-          <p:cNvSpPr txBox="1"/>
-          <p:nvPr/>
-        </p:nvSpPr>
-        <p:spPr>
-          <a:xfrm>
-            <a:off x="548640" y="6400800"/>
+      <p:pic>
+        <p:nvPicPr>
+          <p:cNvPr id="15" name="Image 2" descr="/private/tmp/claude-501/-Users-ulasbudak-Desktop-borsa-app/e78c8e07-ac03-4beb-bcc3-115504839e4a/scratchpad/deck/logo_mark_accent.png">    </p:cNvPr>
+          <p:cNvPicPr>
+            <a:picLocks noChangeAspect="1"/>
+          </p:cNvPicPr>
+          <p:nvPr/>
+        </p:nvPicPr>
+        <p:blipFill>
+          <a:blip r:embed="rId3"/>
+          <a:stretch>
+            <a:fillRect/>
+          </a:stretch>
+        </p:blipFill>
+        <p:spPr>
+          <a:xfrm>
+            <a:off x="548640" y="6437376"/>
+            <a:ext cx="173736" cy="173736"/>
+          </a:xfrm>
+          <a:prstGeom prst="rect">
+            <a:avLst/>
+          </a:prstGeom>
+        </p:spPr>
+      </p:pic>
+      <p:sp>
+        <p:nvSpPr>
+          <p:cNvPr id="16" name="Text 11"/>
+          <p:cNvSpPr txBox="1"/>
+          <p:nvPr/>
+        </p:nvSpPr>
+        <p:spPr>
+          <a:xfrm>
+            <a:off x="786384" y="6400800"/>
             <a:ext cx="2743200" cy="274320"/>
           </a:xfrm>
           <a:prstGeom prst="rect">
@@ -5548,15 +5624,39 @@
           </a:p>
         </p:txBody>
       </p:sp>
-      <p:sp>
-        <p:nvSpPr>
-          <p:cNvPr id="15" name="Text 11"/>
-          <p:cNvSpPr txBox="1"/>
-          <p:nvPr/>
-        </p:nvSpPr>
-        <p:spPr>
-          <a:xfrm>
-            <a:off x="548640" y="6400800"/>
+      <p:pic>
+        <p:nvPicPr>
+          <p:cNvPr id="15" name="Image 2" descr="/private/tmp/claude-501/-Users-ulasbudak-Desktop-borsa-app/e78c8e07-ac03-4beb-bcc3-115504839e4a/scratchpad/deck/logo_mark_accent.png">    </p:cNvPr>
+          <p:cNvPicPr>
+            <a:picLocks noChangeAspect="1"/>
+          </p:cNvPicPr>
+          <p:nvPr/>
+        </p:nvPicPr>
+        <p:blipFill>
+          <a:blip r:embed="rId3"/>
+          <a:stretch>
+            <a:fillRect/>
+          </a:stretch>
+        </p:blipFill>
+        <p:spPr>
+          <a:xfrm>
+            <a:off x="548640" y="6437376"/>
+            <a:ext cx="173736" cy="173736"/>
+          </a:xfrm>
+          <a:prstGeom prst="rect">
+            <a:avLst/>
+          </a:prstGeom>
+        </p:spPr>
+      </p:pic>
+      <p:sp>
+        <p:nvSpPr>
+          <p:cNvPr id="16" name="Text 11"/>
+          <p:cNvSpPr txBox="1"/>
+          <p:nvPr/>
+        </p:nvSpPr>
+        <p:spPr>
+          <a:xfrm>
+            <a:off x="786384" y="6400800"/>
             <a:ext cx="2743200" cy="274320"/>
           </a:xfrm>
           <a:prstGeom prst="rect">
@@ -5634,29 +5734,33 @@
           <a:ln/>
         </p:spPr>
       </p:sp>
-      <p:sp>
-        <p:nvSpPr>
-          <p:cNvPr id="3" name="Shape 1"/>
-          <p:cNvSpPr/>
-          <p:nvPr/>
-        </p:nvSpPr>
-        <p:spPr>
-          <a:xfrm rot="16200000">
-            <a:off x="822960" y="822960"/>
-            <a:ext cx="777240" cy="658368"/>
-          </a:xfrm>
-          <a:prstGeom prst="chevron">
-            <a:avLst/>
-          </a:prstGeom>
-          <a:solidFill>
-            <a:srgbClr val="3B82F6"/>
-          </a:solidFill>
-          <a:ln/>
-        </p:spPr>
-      </p:sp>
-      <p:sp>
-        <p:nvSpPr>
-          <p:cNvPr id="4" name="Text 2"/>
+      <p:pic>
+        <p:nvPicPr>
+          <p:cNvPr id="3" name="Image 0" descr="/private/tmp/claude-501/-Users-ulasbudak-Desktop-borsa-app/e78c8e07-ac03-4beb-bcc3-115504839e4a/scratchpad/deck/logo_mark_accent.png">    </p:cNvPr>
+          <p:cNvPicPr>
+            <a:picLocks noChangeAspect="1"/>
+          </p:cNvPicPr>
+          <p:nvPr/>
+        </p:nvPicPr>
+        <p:blipFill>
+          <a:blip r:embed="rId1"/>
+          <a:stretch>
+            <a:fillRect/>
+          </a:stretch>
+        </p:blipFill>
+        <p:spPr>
+          <a:xfrm>
+            <a:off x="822960" y="777240"/>
+            <a:ext cx="777240" cy="777240"/>
+          </a:xfrm>
+          <a:prstGeom prst="rect">
+            <a:avLst/>
+          </a:prstGeom>
+        </p:spPr>
+      </p:pic>
+      <p:sp>
+        <p:nvSpPr>
+          <p:cNvPr id="4" name="Text 1"/>
           <p:cNvSpPr txBox="1"/>
           <p:nvPr/>
         </p:nvSpPr>
@@ -5695,7 +5799,7 @@
       </p:sp>
       <p:sp>
         <p:nvSpPr>
-          <p:cNvPr id="5" name="Text 3"/>
+          <p:cNvPr id="5" name="Text 2"/>
           <p:cNvSpPr txBox="1"/>
           <p:nvPr/>
         </p:nvSpPr>
@@ -5734,7 +5838,7 @@
       </p:sp>
       <p:sp>
         <p:nvSpPr>
-          <p:cNvPr id="6" name="Shape 4"/>
+          <p:cNvPr id="6" name="Shape 3"/>
           <p:cNvSpPr/>
           <p:nvPr/>
         </p:nvSpPr>
@@ -5768,7 +5872,7 @@
       </p:sp>
       <p:sp>
         <p:nvSpPr>
-          <p:cNvPr id="7" name="Shape 5"/>
+          <p:cNvPr id="7" name="Shape 4"/>
           <p:cNvSpPr/>
           <p:nvPr/>
         </p:nvSpPr>
@@ -5788,14 +5892,14 @@
       </p:sp>
       <p:pic>
         <p:nvPicPr>
-          <p:cNvPr id="8" name="Image 0" descr="/private/tmp/claude-501/-Users-ulasbudak-Desktop-borsa-app/e78c8e07-ac03-4beb-bcc3-115504839e4a/scratchpad/deck/icons/mail-white.png">    </p:cNvPr>
+          <p:cNvPr id="8" name="Image 1" descr="/private/tmp/claude-501/-Users-ulasbudak-Desktop-borsa-app/e78c8e07-ac03-4beb-bcc3-115504839e4a/scratchpad/deck/icons/mail-white.png">    </p:cNvPr>
           <p:cNvPicPr>
             <a:picLocks noChangeAspect="1"/>
           </p:cNvPicPr>
           <p:nvPr/>
         </p:nvPicPr>
         <p:blipFill>
-          <a:blip r:embed="rId1"/>
+          <a:blip r:embed="rId2"/>
           <a:stretch>
             <a:fillRect/>
           </a:stretch>
@@ -5812,7 +5916,7 @@
       </p:pic>
       <p:sp>
         <p:nvSpPr>
-          <p:cNvPr id="9" name="Text 6"/>
+          <p:cNvPr id="9" name="Text 5"/>
           <p:cNvSpPr txBox="1"/>
           <p:nvPr/>
         </p:nvSpPr>
@@ -5851,7 +5955,7 @@
       </p:sp>
       <p:sp>
         <p:nvSpPr>
-          <p:cNvPr id="10" name="Text 7"/>
+          <p:cNvPr id="10" name="Text 6"/>
           <p:cNvSpPr txBox="1"/>
           <p:nvPr/>
         </p:nvSpPr>
@@ -6705,15 +6809,39 @@
           </a:p>
         </p:txBody>
       </p:sp>
-      <p:sp>
-        <p:nvSpPr>
-          <p:cNvPr id="26" name="Text 20"/>
-          <p:cNvSpPr txBox="1"/>
-          <p:nvPr/>
-        </p:nvSpPr>
-        <p:spPr>
-          <a:xfrm>
-            <a:off x="548640" y="6400800"/>
+      <p:pic>
+        <p:nvPicPr>
+          <p:cNvPr id="26" name="Image 4" descr="/private/tmp/claude-501/-Users-ulasbudak-Desktop-borsa-app/e78c8e07-ac03-4beb-bcc3-115504839e4a/scratchpad/deck/logo_mark_accent.png">    </p:cNvPr>
+          <p:cNvPicPr>
+            <a:picLocks noChangeAspect="1"/>
+          </p:cNvPicPr>
+          <p:nvPr/>
+        </p:nvPicPr>
+        <p:blipFill>
+          <a:blip r:embed="rId5"/>
+          <a:stretch>
+            <a:fillRect/>
+          </a:stretch>
+        </p:blipFill>
+        <p:spPr>
+          <a:xfrm>
+            <a:off x="548640" y="6437376"/>
+            <a:ext cx="173736" cy="173736"/>
+          </a:xfrm>
+          <a:prstGeom prst="rect">
+            <a:avLst/>
+          </a:prstGeom>
+        </p:spPr>
+      </p:pic>
+      <p:sp>
+        <p:nvSpPr>
+          <p:cNvPr id="27" name="Text 20"/>
+          <p:cNvSpPr txBox="1"/>
+          <p:nvPr/>
+        </p:nvSpPr>
+        <p:spPr>
+          <a:xfrm>
+            <a:off x="786384" y="6400800"/>
             <a:ext cx="2743200" cy="274320"/>
           </a:xfrm>
           <a:prstGeom prst="rect">
@@ -7439,15 +7567,39 @@
           </a:p>
         </p:txBody>
       </p:sp>
-      <p:sp>
-        <p:nvSpPr>
-          <p:cNvPr id="22" name="Text 17"/>
-          <p:cNvSpPr txBox="1"/>
-          <p:nvPr/>
-        </p:nvSpPr>
-        <p:spPr>
-          <a:xfrm>
-            <a:off x="548640" y="6400800"/>
+      <p:pic>
+        <p:nvPicPr>
+          <p:cNvPr id="22" name="Image 3" descr="/private/tmp/claude-501/-Users-ulasbudak-Desktop-borsa-app/e78c8e07-ac03-4beb-bcc3-115504839e4a/scratchpad/deck/logo_mark_accent.png">    </p:cNvPr>
+          <p:cNvPicPr>
+            <a:picLocks noChangeAspect="1"/>
+          </p:cNvPicPr>
+          <p:nvPr/>
+        </p:nvPicPr>
+        <p:blipFill>
+          <a:blip r:embed="rId4"/>
+          <a:stretch>
+            <a:fillRect/>
+          </a:stretch>
+        </p:blipFill>
+        <p:spPr>
+          <a:xfrm>
+            <a:off x="548640" y="6437376"/>
+            <a:ext cx="173736" cy="173736"/>
+          </a:xfrm>
+          <a:prstGeom prst="rect">
+            <a:avLst/>
+          </a:prstGeom>
+        </p:spPr>
+      </p:pic>
+      <p:sp>
+        <p:nvSpPr>
+          <p:cNvPr id="23" name="Text 17"/>
+          <p:cNvSpPr txBox="1"/>
+          <p:nvPr/>
+        </p:nvSpPr>
+        <p:spPr>
+          <a:xfrm>
+            <a:off x="786384" y="6400800"/>
             <a:ext cx="2743200" cy="274320"/>
           </a:xfrm>
           <a:prstGeom prst="rect">
@@ -8916,15 +9068,39 @@
           </a:p>
         </p:txBody>
       </p:sp>
-      <p:sp>
-        <p:nvSpPr>
-          <p:cNvPr id="45" name="Text 35"/>
-          <p:cNvSpPr txBox="1"/>
-          <p:nvPr/>
-        </p:nvSpPr>
-        <p:spPr>
-          <a:xfrm>
-            <a:off x="548640" y="6400800"/>
+      <p:pic>
+        <p:nvPicPr>
+          <p:cNvPr id="45" name="Image 8" descr="/private/tmp/claude-501/-Users-ulasbudak-Desktop-borsa-app/e78c8e07-ac03-4beb-bcc3-115504839e4a/scratchpad/deck/logo_mark_accent.png">    </p:cNvPr>
+          <p:cNvPicPr>
+            <a:picLocks noChangeAspect="1"/>
+          </p:cNvPicPr>
+          <p:nvPr/>
+        </p:nvPicPr>
+        <p:blipFill>
+          <a:blip r:embed="rId9"/>
+          <a:stretch>
+            <a:fillRect/>
+          </a:stretch>
+        </p:blipFill>
+        <p:spPr>
+          <a:xfrm>
+            <a:off x="548640" y="6437376"/>
+            <a:ext cx="173736" cy="173736"/>
+          </a:xfrm>
+          <a:prstGeom prst="rect">
+            <a:avLst/>
+          </a:prstGeom>
+        </p:spPr>
+      </p:pic>
+      <p:sp>
+        <p:nvSpPr>
+          <p:cNvPr id="46" name="Text 35"/>
+          <p:cNvSpPr txBox="1"/>
+          <p:nvPr/>
+        </p:nvSpPr>
+        <p:spPr>
+          <a:xfrm>
+            <a:off x="786384" y="6400800"/>
             <a:ext cx="2743200" cy="274320"/>
           </a:xfrm>
           <a:prstGeom prst="rect">
@@ -9829,15 +10005,39 @@
           </a:p>
         </p:txBody>
       </p:sp>
-      <p:sp>
-        <p:nvSpPr>
-          <p:cNvPr id="27" name="Text 22"/>
-          <p:cNvSpPr txBox="1"/>
-          <p:nvPr/>
-        </p:nvSpPr>
-        <p:spPr>
-          <a:xfrm>
-            <a:off x="548640" y="6400800"/>
+      <p:pic>
+        <p:nvPicPr>
+          <p:cNvPr id="27" name="Image 3" descr="/private/tmp/claude-501/-Users-ulasbudak-Desktop-borsa-app/e78c8e07-ac03-4beb-bcc3-115504839e4a/scratchpad/deck/logo_mark_accent.png">    </p:cNvPr>
+          <p:cNvPicPr>
+            <a:picLocks noChangeAspect="1"/>
+          </p:cNvPicPr>
+          <p:nvPr/>
+        </p:nvPicPr>
+        <p:blipFill>
+          <a:blip r:embed="rId4"/>
+          <a:stretch>
+            <a:fillRect/>
+          </a:stretch>
+        </p:blipFill>
+        <p:spPr>
+          <a:xfrm>
+            <a:off x="548640" y="6437376"/>
+            <a:ext cx="173736" cy="173736"/>
+          </a:xfrm>
+          <a:prstGeom prst="rect">
+            <a:avLst/>
+          </a:prstGeom>
+        </p:spPr>
+      </p:pic>
+      <p:sp>
+        <p:nvSpPr>
+          <p:cNvPr id="28" name="Text 22"/>
+          <p:cNvSpPr txBox="1"/>
+          <p:nvPr/>
+        </p:nvSpPr>
+        <p:spPr>
+          <a:xfrm>
+            <a:off x="786384" y="6400800"/>
             <a:ext cx="2743200" cy="274320"/>
           </a:xfrm>
           <a:prstGeom prst="rect">
@@ -12042,15 +12242,39 @@
           </a:p>
         </p:txBody>
       </p:sp>
-      <p:sp>
-        <p:nvSpPr>
-          <p:cNvPr id="68" name="Text 66"/>
-          <p:cNvSpPr txBox="1"/>
-          <p:nvPr/>
-        </p:nvSpPr>
-        <p:spPr>
-          <a:xfrm>
-            <a:off x="548640" y="6400800"/>
+      <p:pic>
+        <p:nvPicPr>
+          <p:cNvPr id="68" name="Image 0" descr="/private/tmp/claude-501/-Users-ulasbudak-Desktop-borsa-app/e78c8e07-ac03-4beb-bcc3-115504839e4a/scratchpad/deck/logo_mark_accent.png">    </p:cNvPr>
+          <p:cNvPicPr>
+            <a:picLocks noChangeAspect="1"/>
+          </p:cNvPicPr>
+          <p:nvPr/>
+        </p:nvPicPr>
+        <p:blipFill>
+          <a:blip r:embed="rId1"/>
+          <a:stretch>
+            <a:fillRect/>
+          </a:stretch>
+        </p:blipFill>
+        <p:spPr>
+          <a:xfrm>
+            <a:off x="548640" y="6437376"/>
+            <a:ext cx="173736" cy="173736"/>
+          </a:xfrm>
+          <a:prstGeom prst="rect">
+            <a:avLst/>
+          </a:prstGeom>
+        </p:spPr>
+      </p:pic>
+      <p:sp>
+        <p:nvSpPr>
+          <p:cNvPr id="69" name="Text 66"/>
+          <p:cNvSpPr txBox="1"/>
+          <p:nvPr/>
+        </p:nvSpPr>
+        <p:spPr>
+          <a:xfrm>
+            <a:off x="786384" y="6400800"/>
             <a:ext cx="2743200" cy="274320"/>
           </a:xfrm>
           <a:prstGeom prst="rect">
@@ -13021,15 +13245,39 @@
           </a:p>
         </p:txBody>
       </p:sp>
-      <p:sp>
-        <p:nvSpPr>
-          <p:cNvPr id="27" name="Text 23"/>
-          <p:cNvSpPr txBox="1"/>
-          <p:nvPr/>
-        </p:nvSpPr>
-        <p:spPr>
-          <a:xfrm>
-            <a:off x="548640" y="6400800"/>
+      <p:pic>
+        <p:nvPicPr>
+          <p:cNvPr id="27" name="Image 2" descr="/private/tmp/claude-501/-Users-ulasbudak-Desktop-borsa-app/e78c8e07-ac03-4beb-bcc3-115504839e4a/scratchpad/deck/logo_mark_accent.png">    </p:cNvPr>
+          <p:cNvPicPr>
+            <a:picLocks noChangeAspect="1"/>
+          </p:cNvPicPr>
+          <p:nvPr/>
+        </p:nvPicPr>
+        <p:blipFill>
+          <a:blip r:embed="rId3"/>
+          <a:stretch>
+            <a:fillRect/>
+          </a:stretch>
+        </p:blipFill>
+        <p:spPr>
+          <a:xfrm>
+            <a:off x="548640" y="6437376"/>
+            <a:ext cx="173736" cy="173736"/>
+          </a:xfrm>
+          <a:prstGeom prst="rect">
+            <a:avLst/>
+          </a:prstGeom>
+        </p:spPr>
+      </p:pic>
+      <p:sp>
+        <p:nvSpPr>
+          <p:cNvPr id="28" name="Text 23"/>
+          <p:cNvSpPr txBox="1"/>
+          <p:nvPr/>
+        </p:nvSpPr>
+        <p:spPr>
+          <a:xfrm>
+            <a:off x="786384" y="6400800"/>
             <a:ext cx="2743200" cy="274320"/>
           </a:xfrm>
           <a:prstGeom prst="rect">
@@ -14420,15 +14668,39 @@
           </a:p>
         </p:txBody>
       </p:sp>
-      <p:sp>
-        <p:nvSpPr>
-          <p:cNvPr id="47" name="Text 33"/>
-          <p:cNvSpPr txBox="1"/>
-          <p:nvPr/>
-        </p:nvSpPr>
-        <p:spPr>
-          <a:xfrm>
-            <a:off x="548640" y="6400800"/>
+      <p:pic>
+        <p:nvPicPr>
+          <p:cNvPr id="47" name="Image 12" descr="/private/tmp/claude-501/-Users-ulasbudak-Desktop-borsa-app/e78c8e07-ac03-4beb-bcc3-115504839e4a/scratchpad/deck/logo_mark_accent.png">    </p:cNvPr>
+          <p:cNvPicPr>
+            <a:picLocks noChangeAspect="1"/>
+          </p:cNvPicPr>
+          <p:nvPr/>
+        </p:nvPicPr>
+        <p:blipFill>
+          <a:blip r:embed="rId13"/>
+          <a:stretch>
+            <a:fillRect/>
+          </a:stretch>
+        </p:blipFill>
+        <p:spPr>
+          <a:xfrm>
+            <a:off x="548640" y="6437376"/>
+            <a:ext cx="173736" cy="173736"/>
+          </a:xfrm>
+          <a:prstGeom prst="rect">
+            <a:avLst/>
+          </a:prstGeom>
+        </p:spPr>
+      </p:pic>
+      <p:sp>
+        <p:nvSpPr>
+          <p:cNvPr id="48" name="Text 33"/>
+          <p:cNvSpPr txBox="1"/>
+          <p:nvPr/>
+        </p:nvSpPr>
+        <p:spPr>
+          <a:xfrm>
+            <a:off x="786384" y="6400800"/>
             <a:ext cx="2743200" cy="274320"/>
           </a:xfrm>
           <a:prstGeom prst="rect">
@@ -16062,15 +16334,39 @@
           </a:p>
         </p:txBody>
       </p:sp>
-      <p:sp>
-        <p:nvSpPr>
-          <p:cNvPr id="43" name="Text 38"/>
-          <p:cNvSpPr txBox="1"/>
-          <p:nvPr/>
-        </p:nvSpPr>
-        <p:spPr>
-          <a:xfrm>
-            <a:off x="548640" y="6400800"/>
+      <p:pic>
+        <p:nvPicPr>
+          <p:cNvPr id="43" name="Image 3" descr="/private/tmp/claude-501/-Users-ulasbudak-Desktop-borsa-app/e78c8e07-ac03-4beb-bcc3-115504839e4a/scratchpad/deck/logo_mark_accent.png">    </p:cNvPr>
+          <p:cNvPicPr>
+            <a:picLocks noChangeAspect="1"/>
+          </p:cNvPicPr>
+          <p:nvPr/>
+        </p:nvPicPr>
+        <p:blipFill>
+          <a:blip r:embed="rId4"/>
+          <a:stretch>
+            <a:fillRect/>
+          </a:stretch>
+        </p:blipFill>
+        <p:spPr>
+          <a:xfrm>
+            <a:off x="548640" y="6437376"/>
+            <a:ext cx="173736" cy="173736"/>
+          </a:xfrm>
+          <a:prstGeom prst="rect">
+            <a:avLst/>
+          </a:prstGeom>
+        </p:spPr>
+      </p:pic>
+      <p:sp>
+        <p:nvSpPr>
+          <p:cNvPr id="44" name="Text 38"/>
+          <p:cNvSpPr txBox="1"/>
+          <p:nvPr/>
+        </p:nvSpPr>
+        <p:spPr>
+          <a:xfrm>
+            <a:off x="786384" y="6400800"/>
             <a:ext cx="2743200" cy="274320"/>
           </a:xfrm>
           <a:prstGeom prst="rect">

</xml_diff>